<commit_message>
Add Thank You / Questions closing slide to the deck
Appended a final slide with team credits, course, live demo URL, and
source repo link. Duplicated from the existing Conclusion slide so the
visual style matches the rest of the deck.

Co-Authored-By: Claude Opus 4.6 (1M context) <noreply@anthropic.com>
</commit_message>
<xml_diff>
--- a/presentation/CIS4930 UG Group 3 Project Presentation - FINAL.pptx
+++ b/presentation/CIS4930 UG Group 3 Project Presentation - FINAL.pptx
@@ -18,6 +18,7 @@
     <p:sldId id="260" r:id="rId10"/>
     <p:sldId id="262" r:id="rId11"/>
     <p:sldId id="263" r:id="rId12"/>
+    <p:sldId id="270" r:id="rId20"/>
   </p:sldIdLst>
   <p:sldSz cx="12192000" cy="6858000"/>
   <p:notesSz cx="6858000" cy="9144000"/>
@@ -8282,6 +8283,385 @@
 </p:sld>
 </file>
 
+<file path=ppt/slides/slide14.xml><?xml version="1.0" encoding="utf-8"?>
+<p:sld xmlns:a="http://schemas.openxmlformats.org/drawingml/2006/main" xmlns:p="http://schemas.openxmlformats.org/presentationml/2006/main" xmlns:r="http://schemas.openxmlformats.org/officeDocument/2006/relationships">
+  <p:cSld>
+    <p:spTree>
+      <p:nvGrpSpPr>
+        <p:cNvPr id="1" name=""/>
+        <p:cNvGrpSpPr/>
+        <p:nvPr/>
+      </p:nvGrpSpPr>
+      <p:grpSpPr/>
+      <p:sp useBgFill="1">
+        <p:nvSpPr>
+          <p:cNvPr id="21" name="Rectangle 20">
+            <a:extLst>
+              <a:ext uri="{FF2B5EF4-FFF2-40B4-BE49-F238E27FC236}">
+                <a16:creationId xmlns:a16="http://schemas.microsoft.com/office/drawing/2014/main" id="{89D3A361-AA9F-F785-A4E2-D8DD1E92ED20}"/>
+              </a:ext>
+              <a:ext uri="{C183D7F6-B498-43B3-948B-1728B52AA6E4}">
+                <adec:decorative xmlns:adec="http://schemas.microsoft.com/office/drawing/2017/decorative" val="1"/>
+              </a:ext>
+            </a:extLst>
+          </p:cNvPr>
+          <p:cNvSpPr>
+            <a:spLocks noGrp="1" noRot="1" noChangeAspect="1" noMove="1" noResize="1" noEditPoints="1" noAdjustHandles="1" noChangeArrowheads="1" noChangeShapeType="1" noTextEdit="1"/>
+          </p:cNvSpPr>
+          <p:nvPr>
+            <p:extLst>
+              <p:ext uri="{386F3935-93C4-4BCD-93E2-E3B085C9AB24}">
+                <p16:designElem xmlns:p16="http://schemas.microsoft.com/office/powerpoint/2015/main" val="1"/>
+              </p:ext>
+            </p:extLst>
+          </p:nvPr>
+        </p:nvSpPr>
+        <p:spPr bwMode="white">
+          <a:xfrm>
+            <a:off x="0" y="0"/>
+            <a:ext cx="12192000" cy="6858000"/>
+          </a:xfrm>
+          <a:prstGeom prst="rect">
+            <a:avLst/>
+          </a:prstGeom>
+          <a:ln>
+            <a:noFill/>
+          </a:ln>
+        </p:spPr>
+        <p:style>
+          <a:lnRef idx="2">
+            <a:schemeClr val="accent1">
+              <a:shade val="50000"/>
+            </a:schemeClr>
+          </a:lnRef>
+          <a:fillRef idx="1">
+            <a:schemeClr val="accent1"/>
+          </a:fillRef>
+          <a:effectRef idx="0">
+            <a:schemeClr val="accent1"/>
+          </a:effectRef>
+          <a:fontRef idx="minor">
+            <a:schemeClr val="lt1"/>
+          </a:fontRef>
+        </p:style>
+        <p:txBody>
+          <a:bodyPr rtlCol="0" anchor="ctr"/>
+          <a:lstStyle>
+            <a:defPPr>
+              <a:defRPr lang="en-US"/>
+            </a:defPPr>
+            <a:lvl1pPr marL="0" algn="l" defTabSz="914400" rtl="0" eaLnBrk="1" latinLnBrk="0" hangingPunct="1">
+              <a:defRPr sz="1800" kern="1200">
+                <a:solidFill>
+                  <a:schemeClr val="lt1"/>
+                </a:solidFill>
+                <a:latin typeface="+mn-lt"/>
+                <a:ea typeface="+mn-ea"/>
+                <a:cs typeface="+mn-cs"/>
+              </a:defRPr>
+            </a:lvl1pPr>
+            <a:lvl2pPr marL="457200" algn="l" defTabSz="914400" rtl="0" eaLnBrk="1" latinLnBrk="0" hangingPunct="1">
+              <a:defRPr sz="1800" kern="1200">
+                <a:solidFill>
+                  <a:schemeClr val="lt1"/>
+                </a:solidFill>
+                <a:latin typeface="+mn-lt"/>
+                <a:ea typeface="+mn-ea"/>
+                <a:cs typeface="+mn-cs"/>
+              </a:defRPr>
+            </a:lvl2pPr>
+            <a:lvl3pPr marL="914400" algn="l" defTabSz="914400" rtl="0" eaLnBrk="1" latinLnBrk="0" hangingPunct="1">
+              <a:defRPr sz="1800" kern="1200">
+                <a:solidFill>
+                  <a:schemeClr val="lt1"/>
+                </a:solidFill>
+                <a:latin typeface="+mn-lt"/>
+                <a:ea typeface="+mn-ea"/>
+                <a:cs typeface="+mn-cs"/>
+              </a:defRPr>
+            </a:lvl3pPr>
+            <a:lvl4pPr marL="1371600" algn="l" defTabSz="914400" rtl="0" eaLnBrk="1" latinLnBrk="0" hangingPunct="1">
+              <a:defRPr sz="1800" kern="1200">
+                <a:solidFill>
+                  <a:schemeClr val="lt1"/>
+                </a:solidFill>
+                <a:latin typeface="+mn-lt"/>
+                <a:ea typeface="+mn-ea"/>
+                <a:cs typeface="+mn-cs"/>
+              </a:defRPr>
+            </a:lvl4pPr>
+            <a:lvl5pPr marL="1828800" algn="l" defTabSz="914400" rtl="0" eaLnBrk="1" latinLnBrk="0" hangingPunct="1">
+              <a:defRPr sz="1800" kern="1200">
+                <a:solidFill>
+                  <a:schemeClr val="lt1"/>
+                </a:solidFill>
+                <a:latin typeface="+mn-lt"/>
+                <a:ea typeface="+mn-ea"/>
+                <a:cs typeface="+mn-cs"/>
+              </a:defRPr>
+            </a:lvl5pPr>
+            <a:lvl6pPr marL="2286000" algn="l" defTabSz="914400" rtl="0" eaLnBrk="1" latinLnBrk="0" hangingPunct="1">
+              <a:defRPr sz="1800" kern="1200">
+                <a:solidFill>
+                  <a:schemeClr val="lt1"/>
+                </a:solidFill>
+                <a:latin typeface="+mn-lt"/>
+                <a:ea typeface="+mn-ea"/>
+                <a:cs typeface="+mn-cs"/>
+              </a:defRPr>
+            </a:lvl6pPr>
+            <a:lvl7pPr marL="2743200" algn="l" defTabSz="914400" rtl="0" eaLnBrk="1" latinLnBrk="0" hangingPunct="1">
+              <a:defRPr sz="1800" kern="1200">
+                <a:solidFill>
+                  <a:schemeClr val="lt1"/>
+                </a:solidFill>
+                <a:latin typeface="+mn-lt"/>
+                <a:ea typeface="+mn-ea"/>
+                <a:cs typeface="+mn-cs"/>
+              </a:defRPr>
+            </a:lvl7pPr>
+            <a:lvl8pPr marL="3200400" algn="l" defTabSz="914400" rtl="0" eaLnBrk="1" latinLnBrk="0" hangingPunct="1">
+              <a:defRPr sz="1800" kern="1200">
+                <a:solidFill>
+                  <a:schemeClr val="lt1"/>
+                </a:solidFill>
+                <a:latin typeface="+mn-lt"/>
+                <a:ea typeface="+mn-ea"/>
+                <a:cs typeface="+mn-cs"/>
+              </a:defRPr>
+            </a:lvl8pPr>
+            <a:lvl9pPr marL="3657600" algn="l" defTabSz="914400" rtl="0" eaLnBrk="1" latinLnBrk="0" hangingPunct="1">
+              <a:defRPr sz="1800" kern="1200">
+                <a:solidFill>
+                  <a:schemeClr val="lt1"/>
+                </a:solidFill>
+                <a:latin typeface="+mn-lt"/>
+                <a:ea typeface="+mn-ea"/>
+                <a:cs typeface="+mn-cs"/>
+              </a:defRPr>
+            </a:lvl9pPr>
+          </a:lstStyle>
+          <a:p>
+            <a:pPr algn="ctr"/>
+            <a:endParaRPr lang="en-US"/>
+          </a:p>
+        </p:txBody>
+      </p:sp>
+      <p:sp>
+        <p:nvSpPr>
+          <p:cNvPr id="2" name="Title 1">
+            <a:extLst>
+              <a:ext uri="{FF2B5EF4-FFF2-40B4-BE49-F238E27FC236}">
+                <a16:creationId xmlns:a16="http://schemas.microsoft.com/office/drawing/2014/main" id="{91A82638-783C-AD92-085F-52B0BBEB0F34}"/>
+              </a:ext>
+            </a:extLst>
+          </p:cNvPr>
+          <p:cNvSpPr>
+            <a:spLocks noGrp="1"/>
+          </p:cNvSpPr>
+          <p:nvPr>
+            <p:ph type="title"/>
+          </p:nvPr>
+        </p:nvSpPr>
+        <p:spPr>
+          <a:xfrm>
+            <a:off x="838201" y="750149"/>
+            <a:ext cx="10864837" cy="967333"/>
+          </a:xfrm>
+        </p:spPr>
+        <p:txBody>
+          <a:bodyPr>
+            <a:normAutofit/>
+          </a:bodyPr>
+          <a:lstStyle/>
+          <a:p>
+            <a:r>
+              <a:t>Thank You</a:t>
+            </a:r>
+          </a:p>
+        </p:txBody>
+      </p:sp>
+      <p:sp>
+        <p:nvSpPr>
+          <p:cNvPr id="23" name="Arc 22">
+            <a:extLst>
+              <a:ext uri="{FF2B5EF4-FFF2-40B4-BE49-F238E27FC236}">
+                <a16:creationId xmlns:a16="http://schemas.microsoft.com/office/drawing/2014/main" id="{C26E2678-56EC-63A7-AE6E-8625D2FE1241}"/>
+              </a:ext>
+              <a:ext uri="{C183D7F6-B498-43B3-948B-1728B52AA6E4}">
+                <adec:decorative xmlns:adec="http://schemas.microsoft.com/office/drawing/2017/decorative" val="1"/>
+              </a:ext>
+            </a:extLst>
+          </p:cNvPr>
+          <p:cNvSpPr>
+            <a:spLocks noGrp="1" noRot="1" noChangeAspect="1" noMove="1" noResize="1" noEditPoints="1" noAdjustHandles="1" noChangeArrowheads="1" noChangeShapeType="1" noTextEdit="1"/>
+          </p:cNvSpPr>
+          <p:nvPr>
+            <p:extLst>
+              <p:ext uri="{386F3935-93C4-4BCD-93E2-E3B085C9AB24}">
+                <p16:designElem xmlns:p16="http://schemas.microsoft.com/office/powerpoint/2015/main" val="1"/>
+              </p:ext>
+            </p:extLst>
+          </p:nvPr>
+        </p:nvSpPr>
+        <p:spPr>
+          <a:xfrm rot="6269068">
+            <a:off x="8717845" y="3339275"/>
+            <a:ext cx="2987899" cy="2987899"/>
+          </a:xfrm>
+          <a:prstGeom prst="arc">
+            <a:avLst>
+              <a:gd name="adj1" fmla="val 14441841"/>
+              <a:gd name="adj2" fmla="val 0"/>
+            </a:avLst>
+          </a:prstGeom>
+          <a:ln w="127000" cap="rnd">
+            <a:solidFill>
+              <a:schemeClr val="accent4"/>
+            </a:solidFill>
+            <a:prstDash val="dash"/>
+            <a:miter lim="800000"/>
+          </a:ln>
+        </p:spPr>
+        <p:style>
+          <a:lnRef idx="1">
+            <a:schemeClr val="accent1"/>
+          </a:lnRef>
+          <a:fillRef idx="0">
+            <a:schemeClr val="accent1"/>
+          </a:fillRef>
+          <a:effectRef idx="0">
+            <a:schemeClr val="accent1"/>
+          </a:effectRef>
+          <a:fontRef idx="minor">
+            <a:schemeClr val="tx1"/>
+          </a:fontRef>
+        </p:style>
+        <p:txBody>
+          <a:bodyPr rtlCol="0" anchor="ctr"/>
+          <a:lstStyle/>
+          <a:p>
+            <a:pPr marL="0" marR="0" lvl="0" indent="0" algn="ctr" defTabSz="914400" rtl="0" eaLnBrk="1" fontAlgn="auto" latinLnBrk="0" hangingPunct="1">
+              <a:lnSpc>
+                <a:spcPct val="100000"/>
+              </a:lnSpc>
+              <a:spcBef>
+                <a:spcPts val="0"/>
+              </a:spcBef>
+              <a:spcAft>
+                <a:spcPts val="0"/>
+              </a:spcAft>
+              <a:buClrTx/>
+              <a:buSzTx/>
+              <a:buFontTx/>
+              <a:buNone/>
+              <a:tabLst/>
+              <a:defRPr/>
+            </a:pPr>
+            <a:endParaRPr kumimoji="0" lang="en-US" sz="1800" b="0" i="0" u="none" strike="noStrike" kern="1200" cap="none" spc="0" normalizeH="0" baseline="0" noProof="0">
+              <a:ln>
+                <a:noFill/>
+              </a:ln>
+              <a:solidFill>
+                <a:srgbClr val="000000"/>
+              </a:solidFill>
+              <a:effectLst/>
+              <a:uLnTx/>
+              <a:uFillTx/>
+              <a:latin typeface="Calibri" panose="020F0502020204030204"/>
+              <a:ea typeface="+mn-ea"/>
+              <a:cs typeface="+mn-cs"/>
+            </a:endParaRPr>
+          </a:p>
+        </p:txBody>
+      </p:sp>
+      <p:sp>
+        <p:nvSpPr>
+          <p:cNvPr id="3" name="Content Placeholder 2">
+            <a:extLst>
+              <a:ext uri="{FF2B5EF4-FFF2-40B4-BE49-F238E27FC236}">
+                <a16:creationId xmlns:a16="http://schemas.microsoft.com/office/drawing/2014/main" id="{7AEA285F-C0D9-A258-8A76-37AE5B325F5F}"/>
+              </a:ext>
+            </a:extLst>
+          </p:cNvPr>
+          <p:cNvSpPr>
+            <a:spLocks noGrp="1"/>
+          </p:cNvSpPr>
+          <p:nvPr>
+            <p:ph idx="1"/>
+          </p:nvPr>
+        </p:nvSpPr>
+        <p:spPr>
+          <a:xfrm>
+            <a:off x="836048" y="1524642"/>
+            <a:ext cx="9880669" cy="2216512"/>
+          </a:xfrm>
+        </p:spPr>
+        <p:txBody>
+          <a:bodyPr vert="horz" lIns="91440" tIns="45720" rIns="91440" bIns="45720" rtlCol="0" anchor="t">
+            <a:noAutofit/>
+          </a:bodyPr>
+          <a:lstStyle/>
+          <a:p>
+            <a:pPr marL="342900" indent="-342900" algn="ctr"/>
+            <a:r>
+              <a:rPr sz="4400" b="1"/>
+              <a:t>Questions?</a:t>
+            </a:r>
+            <a:endParaRPr lang="en-US" sz="2400" dirty="0"/>
+          </a:p>
+          <a:p>
+            <a:pPr algn="ctr"/>
+            <a:r>
+              <a:rPr sz="1800" b="0"/>
+              <a:t/>
+            </a:r>
+          </a:p>
+          <a:p>
+            <a:pPr algn="ctr"/>
+            <a:r>
+              <a:rPr sz="2000" b="1"/>
+              <a:t>Tomas Pastore Godoy  ·  Mateo Saettone  ·  Ethan Thompson</a:t>
+            </a:r>
+          </a:p>
+          <a:p>
+            <a:pPr algn="ctr"/>
+            <a:r>
+              <a:rPr sz="1600" b="0"/>
+              <a:t>CIS4930 – Wireless and Mobile Computing</a:t>
+            </a:r>
+          </a:p>
+          <a:p>
+            <a:pPr algn="ctr"/>
+            <a:r>
+              <a:rPr sz="1000" b="0"/>
+              <a:t/>
+            </a:r>
+          </a:p>
+          <a:p>
+            <a:pPr algn="ctr"/>
+            <a:r>
+              <a:rPr sz="1800" b="0"/>
+              <a:t>Live demo:  har-demo-cis4930.vercel.app</a:t>
+            </a:r>
+          </a:p>
+          <a:p>
+            <a:pPr algn="ctr"/>
+            <a:r>
+              <a:rPr sz="1400" b="0"/>
+              <a:t>Source:  github.com/MateoSaettone/Har-Demo</a:t>
+            </a:r>
+          </a:p>
+        </p:txBody>
+      </p:sp>
+    </p:spTree>
+  </p:cSld>
+  <p:clrMapOvr>
+    <a:masterClrMapping/>
+  </p:clrMapOvr>
+</p:sld>
+</file>
+
 <file path=ppt/slides/slide2.xml><?xml version="1.0" encoding="utf-8"?>
 <p:sld xmlns:a="http://schemas.openxmlformats.org/drawingml/2006/main" xmlns:r="http://schemas.openxmlformats.org/officeDocument/2006/relationships" xmlns:p="http://schemas.openxmlformats.org/presentationml/2006/main">
   <p:cSld>

</xml_diff>

<commit_message>
Add tech stack + UI walkthrough slides with live app screenshots
Inserts two new slides between Final Product and Limitations:
- How It Works – end-to-end data flow (DeviceMotion -> 2.56 s window ->
  ONNX Runtime Web -> Supabase Realtime Broadcast -> viewer) and the
  full tech stack (Vercel, Supabase, TensorFlow/tf2onnx, scikit-learn).
- Live Web App – UI Walkthrough: three screenshots (idle, live
  prediction, prediction with project details) with captions and
  explanatory paragraph covering the single-URL / two-role design.

Co-Authored-By: Claude Opus 4.6 (1M context) <noreply@anthropic.com>
</commit_message>
<xml_diff>
--- a/presentation/CIS4930 UG Group 3 Project Presentation - FINAL.pptx
+++ b/presentation/CIS4930 UG Group 3 Project Presentation - FINAL.pptx
@@ -16,9 +16,11 @@
     <p:sldId id="268" r:id="rId18"/>
     <p:sldId id="269" r:id="rId19"/>
     <p:sldId id="260" r:id="rId10"/>
+    <p:sldId id="270" r:id="rId20"/>
+    <p:sldId id="271" r:id="rId21"/>
     <p:sldId id="262" r:id="rId11"/>
     <p:sldId id="263" r:id="rId12"/>
-    <p:sldId id="270" r:id="rId20"/>
+    <p:sldId id="272" r:id="rId22"/>
   </p:sldIdLst>
   <p:sldSz cx="12192000" cy="6858000"/>
   <p:notesSz cx="6858000" cy="9144000"/>
@@ -8298,6 +8300,961 @@
           <p:cNvPr id="21" name="Rectangle 20">
             <a:extLst>
               <a:ext uri="{FF2B5EF4-FFF2-40B4-BE49-F238E27FC236}">
+                <a16:creationId xmlns:a16="http://schemas.microsoft.com/office/drawing/2014/main" id="{DA6FF9C3-6FAF-9130-88BF-EAE463032A9C}"/>
+              </a:ext>
+              <a:ext uri="{C183D7F6-B498-43B3-948B-1728B52AA6E4}">
+                <adec:decorative xmlns:adec="http://schemas.microsoft.com/office/drawing/2017/decorative" val="1"/>
+              </a:ext>
+            </a:extLst>
+          </p:cNvPr>
+          <p:cNvSpPr>
+            <a:spLocks noGrp="1" noRot="1" noChangeAspect="1" noMove="1" noResize="1" noEditPoints="1" noAdjustHandles="1" noChangeArrowheads="1" noChangeShapeType="1" noTextEdit="1"/>
+          </p:cNvSpPr>
+          <p:nvPr>
+            <p:extLst>
+              <p:ext uri="{386F3935-93C4-4BCD-93E2-E3B085C9AB24}">
+                <p16:designElem xmlns:p16="http://schemas.microsoft.com/office/powerpoint/2015/main" val="1"/>
+              </p:ext>
+            </p:extLst>
+          </p:nvPr>
+        </p:nvSpPr>
+        <p:spPr bwMode="white">
+          <a:xfrm>
+            <a:off x="0" y="0"/>
+            <a:ext cx="12192000" cy="6858000"/>
+          </a:xfrm>
+          <a:prstGeom prst="rect">
+            <a:avLst/>
+          </a:prstGeom>
+          <a:ln>
+            <a:noFill/>
+          </a:ln>
+        </p:spPr>
+        <p:style>
+          <a:lnRef idx="2">
+            <a:schemeClr val="accent1">
+              <a:shade val="50000"/>
+            </a:schemeClr>
+          </a:lnRef>
+          <a:fillRef idx="1">
+            <a:schemeClr val="accent1"/>
+          </a:fillRef>
+          <a:effectRef idx="0">
+            <a:schemeClr val="accent1"/>
+          </a:effectRef>
+          <a:fontRef idx="minor">
+            <a:schemeClr val="lt1"/>
+          </a:fontRef>
+        </p:style>
+        <p:txBody>
+          <a:bodyPr rtlCol="0" anchor="ctr"/>
+          <a:lstStyle>
+            <a:defPPr>
+              <a:defRPr lang="en-US"/>
+            </a:defPPr>
+            <a:lvl1pPr marL="0" algn="l" defTabSz="914400" rtl="0" eaLnBrk="1" latinLnBrk="0" hangingPunct="1">
+              <a:defRPr sz="1800" kern="1200">
+                <a:solidFill>
+                  <a:schemeClr val="lt1"/>
+                </a:solidFill>
+                <a:latin typeface="+mn-lt"/>
+                <a:ea typeface="+mn-ea"/>
+                <a:cs typeface="+mn-cs"/>
+              </a:defRPr>
+            </a:lvl1pPr>
+            <a:lvl2pPr marL="457200" algn="l" defTabSz="914400" rtl="0" eaLnBrk="1" latinLnBrk="0" hangingPunct="1">
+              <a:defRPr sz="1800" kern="1200">
+                <a:solidFill>
+                  <a:schemeClr val="lt1"/>
+                </a:solidFill>
+                <a:latin typeface="+mn-lt"/>
+                <a:ea typeface="+mn-ea"/>
+                <a:cs typeface="+mn-cs"/>
+              </a:defRPr>
+            </a:lvl2pPr>
+            <a:lvl3pPr marL="914400" algn="l" defTabSz="914400" rtl="0" eaLnBrk="1" latinLnBrk="0" hangingPunct="1">
+              <a:defRPr sz="1800" kern="1200">
+                <a:solidFill>
+                  <a:schemeClr val="lt1"/>
+                </a:solidFill>
+                <a:latin typeface="+mn-lt"/>
+                <a:ea typeface="+mn-ea"/>
+                <a:cs typeface="+mn-cs"/>
+              </a:defRPr>
+            </a:lvl3pPr>
+            <a:lvl4pPr marL="1371600" algn="l" defTabSz="914400" rtl="0" eaLnBrk="1" latinLnBrk="0" hangingPunct="1">
+              <a:defRPr sz="1800" kern="1200">
+                <a:solidFill>
+                  <a:schemeClr val="lt1"/>
+                </a:solidFill>
+                <a:latin typeface="+mn-lt"/>
+                <a:ea typeface="+mn-ea"/>
+                <a:cs typeface="+mn-cs"/>
+              </a:defRPr>
+            </a:lvl4pPr>
+            <a:lvl5pPr marL="1828800" algn="l" defTabSz="914400" rtl="0" eaLnBrk="1" latinLnBrk="0" hangingPunct="1">
+              <a:defRPr sz="1800" kern="1200">
+                <a:solidFill>
+                  <a:schemeClr val="lt1"/>
+                </a:solidFill>
+                <a:latin typeface="+mn-lt"/>
+                <a:ea typeface="+mn-ea"/>
+                <a:cs typeface="+mn-cs"/>
+              </a:defRPr>
+            </a:lvl5pPr>
+            <a:lvl6pPr marL="2286000" algn="l" defTabSz="914400" rtl="0" eaLnBrk="1" latinLnBrk="0" hangingPunct="1">
+              <a:defRPr sz="1800" kern="1200">
+                <a:solidFill>
+                  <a:schemeClr val="lt1"/>
+                </a:solidFill>
+                <a:latin typeface="+mn-lt"/>
+                <a:ea typeface="+mn-ea"/>
+                <a:cs typeface="+mn-cs"/>
+              </a:defRPr>
+            </a:lvl6pPr>
+            <a:lvl7pPr marL="2743200" algn="l" defTabSz="914400" rtl="0" eaLnBrk="1" latinLnBrk="0" hangingPunct="1">
+              <a:defRPr sz="1800" kern="1200">
+                <a:solidFill>
+                  <a:schemeClr val="lt1"/>
+                </a:solidFill>
+                <a:latin typeface="+mn-lt"/>
+                <a:ea typeface="+mn-ea"/>
+                <a:cs typeface="+mn-cs"/>
+              </a:defRPr>
+            </a:lvl7pPr>
+            <a:lvl8pPr marL="3200400" algn="l" defTabSz="914400" rtl="0" eaLnBrk="1" latinLnBrk="0" hangingPunct="1">
+              <a:defRPr sz="1800" kern="1200">
+                <a:solidFill>
+                  <a:schemeClr val="lt1"/>
+                </a:solidFill>
+                <a:latin typeface="+mn-lt"/>
+                <a:ea typeface="+mn-ea"/>
+                <a:cs typeface="+mn-cs"/>
+              </a:defRPr>
+            </a:lvl8pPr>
+            <a:lvl9pPr marL="3657600" algn="l" defTabSz="914400" rtl="0" eaLnBrk="1" latinLnBrk="0" hangingPunct="1">
+              <a:defRPr sz="1800" kern="1200">
+                <a:solidFill>
+                  <a:schemeClr val="lt1"/>
+                </a:solidFill>
+                <a:latin typeface="+mn-lt"/>
+                <a:ea typeface="+mn-ea"/>
+                <a:cs typeface="+mn-cs"/>
+              </a:defRPr>
+            </a:lvl9pPr>
+          </a:lstStyle>
+          <a:p>
+            <a:pPr algn="ctr"/>
+            <a:endParaRPr lang="en-US"/>
+          </a:p>
+        </p:txBody>
+      </p:sp>
+      <p:sp>
+        <p:nvSpPr>
+          <p:cNvPr id="2" name="Title 1">
+            <a:extLst>
+              <a:ext uri="{FF2B5EF4-FFF2-40B4-BE49-F238E27FC236}">
+                <a16:creationId xmlns:a16="http://schemas.microsoft.com/office/drawing/2014/main" id="{25B68809-6D2D-98DB-1CE1-DED2D74154D5}"/>
+              </a:ext>
+            </a:extLst>
+          </p:cNvPr>
+          <p:cNvSpPr>
+            <a:spLocks noGrp="1"/>
+          </p:cNvSpPr>
+          <p:nvPr>
+            <p:ph type="title"/>
+          </p:nvPr>
+        </p:nvSpPr>
+        <p:spPr>
+          <a:xfrm>
+            <a:off x="838201" y="750149"/>
+            <a:ext cx="10864837" cy="967333"/>
+          </a:xfrm>
+        </p:spPr>
+        <p:txBody>
+          <a:bodyPr>
+            <a:normAutofit/>
+          </a:bodyPr>
+          <a:lstStyle/>
+          <a:p>
+            <a:r>
+              <a:t>How It Works – Tech Stack &amp; Data Flow</a:t>
+            </a:r>
+          </a:p>
+        </p:txBody>
+      </p:sp>
+      <p:sp>
+        <p:nvSpPr>
+          <p:cNvPr id="23" name="Arc 22">
+            <a:extLst>
+              <a:ext uri="{FF2B5EF4-FFF2-40B4-BE49-F238E27FC236}">
+                <a16:creationId xmlns:a16="http://schemas.microsoft.com/office/drawing/2014/main" id="{8BB1D5E5-3F19-3DDC-D0F8-11E7507A4F0D}"/>
+              </a:ext>
+              <a:ext uri="{C183D7F6-B498-43B3-948B-1728B52AA6E4}">
+                <adec:decorative xmlns:adec="http://schemas.microsoft.com/office/drawing/2017/decorative" val="1"/>
+              </a:ext>
+            </a:extLst>
+          </p:cNvPr>
+          <p:cNvSpPr>
+            <a:spLocks noGrp="1" noRot="1" noChangeAspect="1" noMove="1" noResize="1" noEditPoints="1" noAdjustHandles="1" noChangeArrowheads="1" noChangeShapeType="1" noTextEdit="1"/>
+          </p:cNvSpPr>
+          <p:nvPr>
+            <p:extLst>
+              <p:ext uri="{386F3935-93C4-4BCD-93E2-E3B085C9AB24}">
+                <p16:designElem xmlns:p16="http://schemas.microsoft.com/office/powerpoint/2015/main" val="1"/>
+              </p:ext>
+            </p:extLst>
+          </p:nvPr>
+        </p:nvSpPr>
+        <p:spPr>
+          <a:xfrm rot="6269068">
+            <a:off x="8717845" y="3339275"/>
+            <a:ext cx="2987899" cy="2987899"/>
+          </a:xfrm>
+          <a:prstGeom prst="arc">
+            <a:avLst>
+              <a:gd name="adj1" fmla="val 14441841"/>
+              <a:gd name="adj2" fmla="val 0"/>
+            </a:avLst>
+          </a:prstGeom>
+          <a:ln w="127000" cap="rnd">
+            <a:solidFill>
+              <a:schemeClr val="accent4"/>
+            </a:solidFill>
+            <a:prstDash val="dash"/>
+            <a:miter lim="800000"/>
+          </a:ln>
+        </p:spPr>
+        <p:style>
+          <a:lnRef idx="1">
+            <a:schemeClr val="accent1"/>
+          </a:lnRef>
+          <a:fillRef idx="0">
+            <a:schemeClr val="accent1"/>
+          </a:fillRef>
+          <a:effectRef idx="0">
+            <a:schemeClr val="accent1"/>
+          </a:effectRef>
+          <a:fontRef idx="minor">
+            <a:schemeClr val="tx1"/>
+          </a:fontRef>
+        </p:style>
+        <p:txBody>
+          <a:bodyPr rtlCol="0" anchor="ctr"/>
+          <a:lstStyle/>
+          <a:p>
+            <a:pPr marL="0" marR="0" lvl="0" indent="0" algn="ctr" defTabSz="914400" rtl="0" eaLnBrk="1" fontAlgn="auto" latinLnBrk="0" hangingPunct="1">
+              <a:lnSpc>
+                <a:spcPct val="100000"/>
+              </a:lnSpc>
+              <a:spcBef>
+                <a:spcPts val="0"/>
+              </a:spcBef>
+              <a:spcAft>
+                <a:spcPts val="0"/>
+              </a:spcAft>
+              <a:buClrTx/>
+              <a:buSzTx/>
+              <a:buFontTx/>
+              <a:buNone/>
+              <a:tabLst/>
+              <a:defRPr/>
+            </a:pPr>
+            <a:endParaRPr kumimoji="0" lang="en-US" sz="1800" b="0" i="0" u="none" strike="noStrike" kern="1200" cap="none" spc="0" normalizeH="0" baseline="0" noProof="0">
+              <a:ln>
+                <a:noFill/>
+              </a:ln>
+              <a:solidFill>
+                <a:srgbClr val="000000"/>
+              </a:solidFill>
+              <a:effectLst/>
+              <a:uLnTx/>
+              <a:uFillTx/>
+              <a:latin typeface="Calibri" panose="020F0502020204030204"/>
+              <a:ea typeface="+mn-ea"/>
+              <a:cs typeface="+mn-cs"/>
+            </a:endParaRPr>
+          </a:p>
+        </p:txBody>
+      </p:sp>
+      <p:sp>
+        <p:nvSpPr>
+          <p:cNvPr id="3" name="Content Placeholder 2">
+            <a:extLst>
+              <a:ext uri="{FF2B5EF4-FFF2-40B4-BE49-F238E27FC236}">
+                <a16:creationId xmlns:a16="http://schemas.microsoft.com/office/drawing/2014/main" id="{961D05D5-294C-84C4-E5D6-9095291363AD}"/>
+              </a:ext>
+            </a:extLst>
+          </p:cNvPr>
+          <p:cNvSpPr>
+            <a:spLocks noGrp="1"/>
+          </p:cNvSpPr>
+          <p:nvPr>
+            <p:ph idx="1"/>
+          </p:nvPr>
+        </p:nvSpPr>
+        <p:spPr>
+          <a:xfrm>
+            <a:off x="836048" y="1524642"/>
+            <a:ext cx="9880669" cy="2216512"/>
+          </a:xfrm>
+        </p:spPr>
+        <p:txBody>
+          <a:bodyPr vert="horz" lIns="91440" tIns="45720" rIns="91440" bIns="45720" rtlCol="0" anchor="t">
+            <a:noAutofit/>
+          </a:bodyPr>
+          <a:lstStyle/>
+          <a:p>
+            <a:pPr marL="342900" indent="-342900"/>
+            <a:r>
+              <a:t>Data flow (end-to-end, in-browser)</a:t>
+            </a:r>
+            <a:endParaRPr lang="en-US" sz="2400" dirty="0"/>
+          </a:p>
+          <a:p>
+            <a:pPr lvl="1"/>
+            <a:r>
+              <a:t>Phone opens har-demo-cis4930.vercel.app – a Progressive Web App loads</a:t>
+            </a:r>
+          </a:p>
+          <a:p>
+            <a:pPr lvl="1"/>
+            <a:r>
+              <a:t>iOS/Android DeviceMotion API streams accel + gyro at 50–100 Hz</a:t>
+            </a:r>
+          </a:p>
+          <a:p>
+            <a:pPr lvl="1"/>
+            <a:r>
+              <a:t>Sliding 2.56 s window (128 samples × 9 channels, matches UCI HAR)</a:t>
+            </a:r>
+          </a:p>
+          <a:p>
+            <a:pPr lvl="1"/>
+            <a:r>
+              <a:t>ONNX Runtime Web runs the 1D CNN on-device via WebAssembly – no server</a:t>
+            </a:r>
+          </a:p>
+          <a:p>
+            <a:pPr lvl="1"/>
+            <a:r>
+              <a:t>Every ~0.32 s a prediction is published to Supabase Realtime Broadcast</a:t>
+            </a:r>
+          </a:p>
+          <a:p>
+            <a:pPr lvl="1"/>
+            <a:r>
+              <a:t>Any other device on the same URL auto-joins as a viewer and mirrors the label</a:t>
+            </a:r>
+          </a:p>
+          <a:p>
+            <a:pPr/>
+            <a:r>
+              <a:t>Tech stack</a:t>
+            </a:r>
+          </a:p>
+          <a:p>
+            <a:pPr lvl="1"/>
+            <a:r>
+              <a:t>Frontend: vanilla HTML + ES modules (no framework, no build step)</a:t>
+            </a:r>
+          </a:p>
+          <a:p>
+            <a:pPr lvl="1"/>
+            <a:r>
+              <a:t>Inference: ONNX Runtime Web (WASM backend) – model is ~170 KB</a:t>
+            </a:r>
+          </a:p>
+          <a:p>
+            <a:pPr lvl="1"/>
+            <a:r>
+              <a:t>Realtime: Supabase Broadcast – ephemeral pub/sub, no tables or RLS</a:t>
+            </a:r>
+          </a:p>
+          <a:p>
+            <a:pPr lvl="1"/>
+            <a:r>
+              <a:t>Hosting: Vercel static deployment, auto-redeployed on every git push</a:t>
+            </a:r>
+          </a:p>
+          <a:p>
+            <a:pPr lvl="1"/>
+            <a:r>
+              <a:t>Training: Python · TensorFlow / Keras · tf2onnx · scikit-learn (RF baseline)</a:t>
+            </a:r>
+          </a:p>
+          <a:p>
+            <a:pPr lvl="1"/>
+            <a:r>
+              <a:t>Source: github.com/MateoSaettone/Har-Demo</a:t>
+            </a:r>
+          </a:p>
+        </p:txBody>
+      </p:sp>
+    </p:spTree>
+  </p:cSld>
+  <p:clrMapOvr>
+    <a:masterClrMapping/>
+  </p:clrMapOvr>
+</p:sld>
+</file>
+
+<file path=ppt/slides/slide15.xml><?xml version="1.0" encoding="utf-8"?>
+<p:sld xmlns:a="http://schemas.openxmlformats.org/drawingml/2006/main" xmlns:p="http://schemas.openxmlformats.org/presentationml/2006/main" xmlns:r="http://schemas.openxmlformats.org/officeDocument/2006/relationships">
+  <p:cSld>
+    <p:spTree>
+      <p:nvGrpSpPr>
+        <p:cNvPr id="1" name=""/>
+        <p:cNvGrpSpPr/>
+        <p:nvPr/>
+      </p:nvGrpSpPr>
+      <p:grpSpPr/>
+      <p:sp useBgFill="1">
+        <p:nvSpPr>
+          <p:cNvPr id="21" name="Rectangle 20">
+            <a:extLst>
+              <a:ext uri="{FF2B5EF4-FFF2-40B4-BE49-F238E27FC236}">
+                <a16:creationId xmlns:a16="http://schemas.microsoft.com/office/drawing/2014/main" id="{DA6FF9C3-6FAF-9130-88BF-EAE463032A9C}"/>
+              </a:ext>
+              <a:ext uri="{C183D7F6-B498-43B3-948B-1728B52AA6E4}">
+                <adec:decorative xmlns:adec="http://schemas.microsoft.com/office/drawing/2017/decorative" val="1"/>
+              </a:ext>
+            </a:extLst>
+          </p:cNvPr>
+          <p:cNvSpPr>
+            <a:spLocks noGrp="1" noRot="1" noChangeAspect="1" noMove="1" noResize="1" noEditPoints="1" noAdjustHandles="1" noChangeArrowheads="1" noChangeShapeType="1" noTextEdit="1"/>
+          </p:cNvSpPr>
+          <p:nvPr>
+            <p:extLst>
+              <p:ext uri="{386F3935-93C4-4BCD-93E2-E3B085C9AB24}">
+                <p16:designElem xmlns:p16="http://schemas.microsoft.com/office/powerpoint/2015/main" val="1"/>
+              </p:ext>
+            </p:extLst>
+          </p:nvPr>
+        </p:nvSpPr>
+        <p:spPr bwMode="white">
+          <a:xfrm>
+            <a:off x="0" y="0"/>
+            <a:ext cx="12192000" cy="6858000"/>
+          </a:xfrm>
+          <a:prstGeom prst="rect">
+            <a:avLst/>
+          </a:prstGeom>
+          <a:ln>
+            <a:noFill/>
+          </a:ln>
+        </p:spPr>
+        <p:style>
+          <a:lnRef idx="2">
+            <a:schemeClr val="accent1">
+              <a:shade val="50000"/>
+            </a:schemeClr>
+          </a:lnRef>
+          <a:fillRef idx="1">
+            <a:schemeClr val="accent1"/>
+          </a:fillRef>
+          <a:effectRef idx="0">
+            <a:schemeClr val="accent1"/>
+          </a:effectRef>
+          <a:fontRef idx="minor">
+            <a:schemeClr val="lt1"/>
+          </a:fontRef>
+        </p:style>
+        <p:txBody>
+          <a:bodyPr rtlCol="0" anchor="ctr"/>
+          <a:lstStyle>
+            <a:defPPr>
+              <a:defRPr lang="en-US"/>
+            </a:defPPr>
+            <a:lvl1pPr marL="0" algn="l" defTabSz="914400" rtl="0" eaLnBrk="1" latinLnBrk="0" hangingPunct="1">
+              <a:defRPr sz="1800" kern="1200">
+                <a:solidFill>
+                  <a:schemeClr val="lt1"/>
+                </a:solidFill>
+                <a:latin typeface="+mn-lt"/>
+                <a:ea typeface="+mn-ea"/>
+                <a:cs typeface="+mn-cs"/>
+              </a:defRPr>
+            </a:lvl1pPr>
+            <a:lvl2pPr marL="457200" algn="l" defTabSz="914400" rtl="0" eaLnBrk="1" latinLnBrk="0" hangingPunct="1">
+              <a:defRPr sz="1800" kern="1200">
+                <a:solidFill>
+                  <a:schemeClr val="lt1"/>
+                </a:solidFill>
+                <a:latin typeface="+mn-lt"/>
+                <a:ea typeface="+mn-ea"/>
+                <a:cs typeface="+mn-cs"/>
+              </a:defRPr>
+            </a:lvl2pPr>
+            <a:lvl3pPr marL="914400" algn="l" defTabSz="914400" rtl="0" eaLnBrk="1" latinLnBrk="0" hangingPunct="1">
+              <a:defRPr sz="1800" kern="1200">
+                <a:solidFill>
+                  <a:schemeClr val="lt1"/>
+                </a:solidFill>
+                <a:latin typeface="+mn-lt"/>
+                <a:ea typeface="+mn-ea"/>
+                <a:cs typeface="+mn-cs"/>
+              </a:defRPr>
+            </a:lvl3pPr>
+            <a:lvl4pPr marL="1371600" algn="l" defTabSz="914400" rtl="0" eaLnBrk="1" latinLnBrk="0" hangingPunct="1">
+              <a:defRPr sz="1800" kern="1200">
+                <a:solidFill>
+                  <a:schemeClr val="lt1"/>
+                </a:solidFill>
+                <a:latin typeface="+mn-lt"/>
+                <a:ea typeface="+mn-ea"/>
+                <a:cs typeface="+mn-cs"/>
+              </a:defRPr>
+            </a:lvl4pPr>
+            <a:lvl5pPr marL="1828800" algn="l" defTabSz="914400" rtl="0" eaLnBrk="1" latinLnBrk="0" hangingPunct="1">
+              <a:defRPr sz="1800" kern="1200">
+                <a:solidFill>
+                  <a:schemeClr val="lt1"/>
+                </a:solidFill>
+                <a:latin typeface="+mn-lt"/>
+                <a:ea typeface="+mn-ea"/>
+                <a:cs typeface="+mn-cs"/>
+              </a:defRPr>
+            </a:lvl5pPr>
+            <a:lvl6pPr marL="2286000" algn="l" defTabSz="914400" rtl="0" eaLnBrk="1" latinLnBrk="0" hangingPunct="1">
+              <a:defRPr sz="1800" kern="1200">
+                <a:solidFill>
+                  <a:schemeClr val="lt1"/>
+                </a:solidFill>
+                <a:latin typeface="+mn-lt"/>
+                <a:ea typeface="+mn-ea"/>
+                <a:cs typeface="+mn-cs"/>
+              </a:defRPr>
+            </a:lvl6pPr>
+            <a:lvl7pPr marL="2743200" algn="l" defTabSz="914400" rtl="0" eaLnBrk="1" latinLnBrk="0" hangingPunct="1">
+              <a:defRPr sz="1800" kern="1200">
+                <a:solidFill>
+                  <a:schemeClr val="lt1"/>
+                </a:solidFill>
+                <a:latin typeface="+mn-lt"/>
+                <a:ea typeface="+mn-ea"/>
+                <a:cs typeface="+mn-cs"/>
+              </a:defRPr>
+            </a:lvl7pPr>
+            <a:lvl8pPr marL="3200400" algn="l" defTabSz="914400" rtl="0" eaLnBrk="1" latinLnBrk="0" hangingPunct="1">
+              <a:defRPr sz="1800" kern="1200">
+                <a:solidFill>
+                  <a:schemeClr val="lt1"/>
+                </a:solidFill>
+                <a:latin typeface="+mn-lt"/>
+                <a:ea typeface="+mn-ea"/>
+                <a:cs typeface="+mn-cs"/>
+              </a:defRPr>
+            </a:lvl8pPr>
+            <a:lvl9pPr marL="3657600" algn="l" defTabSz="914400" rtl="0" eaLnBrk="1" latinLnBrk="0" hangingPunct="1">
+              <a:defRPr sz="1800" kern="1200">
+                <a:solidFill>
+                  <a:schemeClr val="lt1"/>
+                </a:solidFill>
+                <a:latin typeface="+mn-lt"/>
+                <a:ea typeface="+mn-ea"/>
+                <a:cs typeface="+mn-cs"/>
+              </a:defRPr>
+            </a:lvl9pPr>
+          </a:lstStyle>
+          <a:p>
+            <a:pPr algn="ctr"/>
+            <a:endParaRPr lang="en-US"/>
+          </a:p>
+        </p:txBody>
+      </p:sp>
+      <p:sp>
+        <p:nvSpPr>
+          <p:cNvPr id="2" name="Title 1">
+            <a:extLst>
+              <a:ext uri="{FF2B5EF4-FFF2-40B4-BE49-F238E27FC236}">
+                <a16:creationId xmlns:a16="http://schemas.microsoft.com/office/drawing/2014/main" id="{25B68809-6D2D-98DB-1CE1-DED2D74154D5}"/>
+              </a:ext>
+            </a:extLst>
+          </p:cNvPr>
+          <p:cNvSpPr>
+            <a:spLocks noGrp="1"/>
+          </p:cNvSpPr>
+          <p:nvPr>
+            <p:ph type="title"/>
+          </p:nvPr>
+        </p:nvSpPr>
+        <p:spPr>
+          <a:xfrm>
+            <a:off x="838201" y="750149"/>
+            <a:ext cx="10864837" cy="967333"/>
+          </a:xfrm>
+        </p:spPr>
+        <p:txBody>
+          <a:bodyPr>
+            <a:normAutofit/>
+          </a:bodyPr>
+          <a:lstStyle/>
+          <a:p>
+            <a:r>
+              <a:t>Live Web App – UI Walkthrough</a:t>
+            </a:r>
+          </a:p>
+        </p:txBody>
+      </p:sp>
+      <p:sp>
+        <p:nvSpPr>
+          <p:cNvPr id="23" name="Arc 22">
+            <a:extLst>
+              <a:ext uri="{FF2B5EF4-FFF2-40B4-BE49-F238E27FC236}">
+                <a16:creationId xmlns:a16="http://schemas.microsoft.com/office/drawing/2014/main" id="{8BB1D5E5-3F19-3DDC-D0F8-11E7507A4F0D}"/>
+              </a:ext>
+              <a:ext uri="{C183D7F6-B498-43B3-948B-1728B52AA6E4}">
+                <adec:decorative xmlns:adec="http://schemas.microsoft.com/office/drawing/2017/decorative" val="1"/>
+              </a:ext>
+            </a:extLst>
+          </p:cNvPr>
+          <p:cNvSpPr>
+            <a:spLocks noGrp="1" noRot="1" noChangeAspect="1" noMove="1" noResize="1" noEditPoints="1" noAdjustHandles="1" noChangeArrowheads="1" noChangeShapeType="1" noTextEdit="1"/>
+          </p:cNvSpPr>
+          <p:nvPr>
+            <p:extLst>
+              <p:ext uri="{386F3935-93C4-4BCD-93E2-E3B085C9AB24}">
+                <p16:designElem xmlns:p16="http://schemas.microsoft.com/office/powerpoint/2015/main" val="1"/>
+              </p:ext>
+            </p:extLst>
+          </p:nvPr>
+        </p:nvSpPr>
+        <p:spPr>
+          <a:xfrm rot="6269068">
+            <a:off x="8717845" y="3339275"/>
+            <a:ext cx="2987899" cy="2987899"/>
+          </a:xfrm>
+          <a:prstGeom prst="arc">
+            <a:avLst>
+              <a:gd name="adj1" fmla="val 14441841"/>
+              <a:gd name="adj2" fmla="val 0"/>
+            </a:avLst>
+          </a:prstGeom>
+          <a:ln w="127000" cap="rnd">
+            <a:solidFill>
+              <a:schemeClr val="accent4"/>
+            </a:solidFill>
+            <a:prstDash val="dash"/>
+            <a:miter lim="800000"/>
+          </a:ln>
+        </p:spPr>
+        <p:style>
+          <a:lnRef idx="1">
+            <a:schemeClr val="accent1"/>
+          </a:lnRef>
+          <a:fillRef idx="0">
+            <a:schemeClr val="accent1"/>
+          </a:fillRef>
+          <a:effectRef idx="0">
+            <a:schemeClr val="accent1"/>
+          </a:effectRef>
+          <a:fontRef idx="minor">
+            <a:schemeClr val="tx1"/>
+          </a:fontRef>
+        </p:style>
+        <p:txBody>
+          <a:bodyPr rtlCol="0" anchor="ctr"/>
+          <a:lstStyle/>
+          <a:p>
+            <a:pPr marL="0" marR="0" lvl="0" indent="0" algn="ctr" defTabSz="914400" rtl="0" eaLnBrk="1" fontAlgn="auto" latinLnBrk="0" hangingPunct="1">
+              <a:lnSpc>
+                <a:spcPct val="100000"/>
+              </a:lnSpc>
+              <a:spcBef>
+                <a:spcPts val="0"/>
+              </a:spcBef>
+              <a:spcAft>
+                <a:spcPts val="0"/>
+              </a:spcAft>
+              <a:buClrTx/>
+              <a:buSzTx/>
+              <a:buFontTx/>
+              <a:buNone/>
+              <a:tabLst/>
+              <a:defRPr/>
+            </a:pPr>
+            <a:endParaRPr kumimoji="0" lang="en-US" sz="1800" b="0" i="0" u="none" strike="noStrike" kern="1200" cap="none" spc="0" normalizeH="0" baseline="0" noProof="0">
+              <a:ln>
+                <a:noFill/>
+              </a:ln>
+              <a:solidFill>
+                <a:srgbClr val="000000"/>
+              </a:solidFill>
+              <a:effectLst/>
+              <a:uLnTx/>
+              <a:uFillTx/>
+              <a:latin typeface="Calibri" panose="020F0502020204030204"/>
+              <a:ea typeface="+mn-ea"/>
+              <a:cs typeface="+mn-cs"/>
+            </a:endParaRPr>
+          </a:p>
+        </p:txBody>
+      </p:sp>
+      <p:pic>
+        <p:nvPicPr>
+          <p:cNvPr id="24" name="Picture 23" descr="ui_idle.png"/>
+          <p:cNvPicPr>
+            <a:picLocks noChangeAspect="1"/>
+          </p:cNvPicPr>
+          <p:nvPr/>
+        </p:nvPicPr>
+        <p:blipFill>
+          <a:blip r:embed="rId2"/>
+          <a:stretch>
+            <a:fillRect/>
+          </a:stretch>
+        </p:blipFill>
+        <p:spPr>
+          <a:xfrm>
+            <a:off x="289561" y="1325880"/>
+            <a:ext cx="3749039" cy="1965960"/>
+          </a:xfrm>
+          <a:prstGeom prst="rect">
+            <a:avLst/>
+          </a:prstGeom>
+        </p:spPr>
+      </p:pic>
+      <p:sp>
+        <p:nvSpPr>
+          <p:cNvPr id="25" name="TextBox 24"/>
+          <p:cNvSpPr txBox="1"/>
+          <p:nvPr/>
+        </p:nvSpPr>
+        <p:spPr>
+          <a:xfrm>
+            <a:off x="289561" y="3383280"/>
+            <a:ext cx="3749039" cy="502920"/>
+          </a:xfrm>
+          <a:prstGeom prst="rect">
+            <a:avLst/>
+          </a:prstGeom>
+          <a:noFill/>
+        </p:spPr>
+        <p:txBody>
+          <a:bodyPr wrap="square">
+            <a:spAutoFit/>
+          </a:bodyPr>
+          <a:lstStyle/>
+          <a:p>
+            <a:pPr algn="ctr"/>
+            <a:r>
+              <a:rPr sz="1200" b="1">
+                <a:solidFill>
+                  <a:srgbClr val="222222"/>
+                </a:solidFill>
+              </a:rPr>
+              <a:t>Idle state – awaiting a tracker</a:t>
+            </a:r>
+          </a:p>
+        </p:txBody>
+      </p:sp>
+      <p:pic>
+        <p:nvPicPr>
+          <p:cNvPr id="26" name="Picture 25" descr="ui_laying.png"/>
+          <p:cNvPicPr>
+            <a:picLocks noChangeAspect="1"/>
+          </p:cNvPicPr>
+          <p:nvPr/>
+        </p:nvPicPr>
+        <p:blipFill>
+          <a:blip r:embed="rId3"/>
+          <a:stretch>
+            <a:fillRect/>
+          </a:stretch>
+        </p:blipFill>
+        <p:spPr>
+          <a:xfrm>
+            <a:off x="4221480" y="1325880"/>
+            <a:ext cx="3749039" cy="1965960"/>
+          </a:xfrm>
+          <a:prstGeom prst="rect">
+            <a:avLst/>
+          </a:prstGeom>
+        </p:spPr>
+      </p:pic>
+      <p:sp>
+        <p:nvSpPr>
+          <p:cNvPr id="27" name="TextBox 26"/>
+          <p:cNvSpPr txBox="1"/>
+          <p:nvPr/>
+        </p:nvSpPr>
+        <p:spPr>
+          <a:xfrm>
+            <a:off x="4221480" y="3383280"/>
+            <a:ext cx="3749039" cy="502920"/>
+          </a:xfrm>
+          <a:prstGeom prst="rect">
+            <a:avLst/>
+          </a:prstGeom>
+          <a:noFill/>
+        </p:spPr>
+        <p:txBody>
+          <a:bodyPr wrap="square">
+            <a:spAutoFit/>
+          </a:bodyPr>
+          <a:lstStyle/>
+          <a:p>
+            <a:pPr algn="ctr"/>
+            <a:r>
+              <a:rPr sz="1200" b="1">
+                <a:solidFill>
+                  <a:srgbClr val="222222"/>
+                </a:solidFill>
+              </a:rPr>
+              <a:t>Live prediction streamed to a viewer</a:t>
+            </a:r>
+          </a:p>
+        </p:txBody>
+      </p:sp>
+      <p:pic>
+        <p:nvPicPr>
+          <p:cNvPr id="28" name="Picture 27" descr="ui_walking_details.png"/>
+          <p:cNvPicPr>
+            <a:picLocks noChangeAspect="1"/>
+          </p:cNvPicPr>
+          <p:nvPr/>
+        </p:nvPicPr>
+        <p:blipFill>
+          <a:blip r:embed="rId4"/>
+          <a:stretch>
+            <a:fillRect/>
+          </a:stretch>
+        </p:blipFill>
+        <p:spPr>
+          <a:xfrm>
+            <a:off x="8153399" y="1325880"/>
+            <a:ext cx="3749039" cy="1965960"/>
+          </a:xfrm>
+          <a:prstGeom prst="rect">
+            <a:avLst/>
+          </a:prstGeom>
+        </p:spPr>
+      </p:pic>
+      <p:sp>
+        <p:nvSpPr>
+          <p:cNvPr id="29" name="TextBox 28"/>
+          <p:cNvSpPr txBox="1"/>
+          <p:nvPr/>
+        </p:nvSpPr>
+        <p:spPr>
+          <a:xfrm>
+            <a:off x="8153399" y="3383280"/>
+            <a:ext cx="3749039" cy="502920"/>
+          </a:xfrm>
+          <a:prstGeom prst="rect">
+            <a:avLst/>
+          </a:prstGeom>
+          <a:noFill/>
+        </p:spPr>
+        <p:txBody>
+          <a:bodyPr wrap="square">
+            <a:spAutoFit/>
+          </a:bodyPr>
+          <a:lstStyle/>
+          <a:p>
+            <a:pPr algn="ctr"/>
+            <a:r>
+              <a:rPr sz="1200" b="1">
+                <a:solidFill>
+                  <a:srgbClr val="222222"/>
+                </a:solidFill>
+              </a:rPr>
+              <a:t>Project details expanded on the viewer</a:t>
+            </a:r>
+          </a:p>
+        </p:txBody>
+      </p:sp>
+      <p:sp>
+        <p:nvSpPr>
+          <p:cNvPr id="30" name="TextBox 29"/>
+          <p:cNvSpPr txBox="1"/>
+          <p:nvPr/>
+        </p:nvSpPr>
+        <p:spPr>
+          <a:xfrm>
+            <a:off x="640080" y="4160520"/>
+            <a:ext cx="10881360" cy="2194560"/>
+          </a:xfrm>
+          <a:prstGeom prst="rect">
+            <a:avLst/>
+          </a:prstGeom>
+          <a:noFill/>
+        </p:spPr>
+        <p:txBody>
+          <a:bodyPr wrap="square">
+            <a:spAutoFit/>
+          </a:bodyPr>
+          <a:lstStyle/>
+          <a:p>
+            <a:pPr algn="l"/>
+            <a:r>
+              <a:rPr sz="1600" b="1">
+                <a:solidFill>
+                  <a:srgbClr val="1C1C1C"/>
+                </a:solidFill>
+              </a:rPr>
+              <a:t>Single URL, two auto-detected roles.</a:t>
+            </a:r>
+          </a:p>
+          <a:p>
+            <a:pPr algn="l"/>
+            <a:r>
+              <a:rPr sz="1300" b="0">
+                <a:solidFill>
+                  <a:srgbClr val="1C1C1C"/>
+                </a:solidFill>
+              </a:rPr>
+              <a:t>A device becomes a tracker the moment it taps Start tracking; every other device on the URL automatically becomes a viewer and mirrors the live label in real time — no pairing, no codes, no second app. The huge centered label is sized for readability from across a room when the phone is mirrored to a projector.</a:t>
+            </a:r>
+          </a:p>
+          <a:p>
+            <a:pPr algn="l"/>
+            <a:r>
+              <a:rPr sz="600" b="0">
+                <a:solidFill>
+                  <a:srgbClr val="1C1C1C"/>
+                </a:solidFill>
+              </a:rPr>
+              <a:t/>
+            </a:r>
+          </a:p>
+          <a:p>
+            <a:pPr algn="l"/>
+            <a:r>
+              <a:rPr sz="1300" b="0">
+                <a:solidFill>
+                  <a:srgbClr val="1C1C1C"/>
+                </a:solidFill>
+              </a:rPr>
+              <a:t>On-screen chrome stays minimal: team chips, expandable Project Details with course / instructor / school / dataset / model / pipeline / repo, a Debug panel exposing the raw 9-channel sensor stream and per-class probabilities, and a status pill (idle · viewing · tracking) in the top-right corner.</a:t>
+            </a:r>
+          </a:p>
+        </p:txBody>
+      </p:sp>
+    </p:spTree>
+  </p:cSld>
+  <p:clrMapOvr>
+    <a:masterClrMapping/>
+  </p:clrMapOvr>
+</p:sld>
+</file>
+
+<file path=ppt/slides/slide16.xml><?xml version="1.0" encoding="utf-8"?>
+<p:sld xmlns:a="http://schemas.openxmlformats.org/drawingml/2006/main" xmlns:p="http://schemas.openxmlformats.org/presentationml/2006/main" xmlns:r="http://schemas.openxmlformats.org/officeDocument/2006/relationships">
+  <p:cSld>
+    <p:spTree>
+      <p:nvGrpSpPr>
+        <p:cNvPr id="1" name=""/>
+        <p:cNvGrpSpPr/>
+        <p:nvPr/>
+      </p:nvGrpSpPr>
+      <p:grpSpPr/>
+      <p:sp useBgFill="1">
+        <p:nvSpPr>
+          <p:cNvPr id="21" name="Rectangle 20">
+            <a:extLst>
+              <a:ext uri="{FF2B5EF4-FFF2-40B4-BE49-F238E27FC236}">
                 <a16:creationId xmlns:a16="http://schemas.microsoft.com/office/drawing/2014/main" id="{89D3A361-AA9F-F785-A4E2-D8DD1E92ED20}"/>
               </a:ext>
               <a:ext uri="{C183D7F6-B498-43B3-948B-1728B52AA6E4}">

</xml_diff>